<commit_message>
docs: sync every artifact to the 54-test baseline
</commit_message>
<xml_diff>
--- a/docs/Razorpay_Buildathon_Action_Firewall_Deck.pptx
+++ b/docs/Razorpay_Buildathon_Action_Firewall_Deck.pptx
@@ -2015,6 +2015,10 @@
             <a:prstDash val="solid"/>
           </a:ln>
         </p:spPr>
+        <p:txBody xmlns:a="http://schemas.openxmlformats.org/drawingml/2006/main">
+          <a:bodyPr/>
+          <a:p/>
+        </p:txBody>
       </p:sp>
       <p:sp>
         <p:nvSpPr>
@@ -2050,6 +2054,10 @@
             <a:prstDash val="solid"/>
           </a:ln>
         </p:spPr>
+        <p:txBody xmlns:a="http://schemas.openxmlformats.org/drawingml/2006/main">
+          <a:bodyPr/>
+          <a:p/>
+        </p:txBody>
       </p:sp>
       <p:sp>
         <p:nvSpPr>
@@ -2269,6 +2277,10 @@
             <a:prstDash val="solid"/>
           </a:ln>
         </p:spPr>
+        <p:txBody xmlns:a="http://schemas.openxmlformats.org/drawingml/2006/main">
+          <a:bodyPr/>
+          <a:p/>
+        </p:txBody>
       </p:sp>
       <p:sp>
         <p:nvSpPr>
@@ -2302,6 +2314,10 @@
             <a:prstDash val="solid"/>
           </a:ln>
         </p:spPr>
+        <p:txBody xmlns:a="http://schemas.openxmlformats.org/drawingml/2006/main">
+          <a:bodyPr/>
+          <a:p/>
+        </p:txBody>
       </p:sp>
       <p:sp>
         <p:nvSpPr>
@@ -2383,6 +2399,10 @@
             <a:prstDash val="solid"/>
           </a:ln>
         </p:spPr>
+        <p:txBody xmlns:a="http://schemas.openxmlformats.org/drawingml/2006/main">
+          <a:bodyPr/>
+          <a:p/>
+        </p:txBody>
       </p:sp>
       <p:sp>
         <p:nvSpPr>
@@ -2416,6 +2436,10 @@
             <a:prstDash val="solid"/>
           </a:ln>
         </p:spPr>
+        <p:txBody xmlns:a="http://schemas.openxmlformats.org/drawingml/2006/main">
+          <a:bodyPr/>
+          <a:p/>
+        </p:txBody>
       </p:sp>
       <p:sp>
         <p:nvSpPr>
@@ -2549,7 +2573,7 @@
                 <a:ea typeface="Courier New"/>
                 <a:cs typeface="Courier New"/>
               </a:rPr>
-              <a:t>Razorpay MCP-compatible actuator  ·  deterministic policy  ·  51 tests  ·  offline demo</a:t>
+              <a:t>Razorpay MCP-compatible actuator  ·  deterministic policy  ·  54 tests  ·  offline demo</a:t>
             </a:r>
             <a:endParaRPr sz="1050"/>
           </a:p>
@@ -2618,6 +2642,10 @@
             <a:prstDash val="solid"/>
           </a:ln>
         </p:spPr>
+        <p:txBody xmlns:a="http://schemas.openxmlformats.org/drawingml/2006/main">
+          <a:bodyPr/>
+          <a:p/>
+        </p:txBody>
       </p:sp>
       <p:sp>
         <p:nvSpPr>
@@ -2808,6 +2836,10 @@
             <a:prstDash val="solid"/>
           </a:ln>
         </p:spPr>
+        <p:txBody xmlns:a="http://schemas.openxmlformats.org/drawingml/2006/main">
+          <a:bodyPr/>
+          <a:p/>
+        </p:txBody>
       </p:sp>
       <p:sp>
         <p:nvSpPr>
@@ -2841,6 +2873,10 @@
             <a:prstDash val="solid"/>
           </a:ln>
         </p:spPr>
+        <p:txBody xmlns:a="http://schemas.openxmlformats.org/drawingml/2006/main">
+          <a:bodyPr/>
+          <a:p/>
+        </p:txBody>
       </p:sp>
       <p:sp>
         <p:nvSpPr>
@@ -2882,7 +2918,7 @@
                 <a:ea typeface="Courier New"/>
                 <a:cs typeface="Courier New"/>
               </a:rPr>
-              <a:t>pytest -q → 51 passed   ·   npm audit → 0   ·   offline rehearsal → passed</a:t>
+              <a:t>pytest -q → 54 passed   ·   npm audit → 0   ·   offline rehearsal → passed</a:t>
             </a:r>
             <a:endParaRPr sz="1050"/>
           </a:p>
@@ -3135,6 +3171,10 @@
             <a:prstDash val="solid"/>
           </a:ln>
         </p:spPr>
+        <p:txBody xmlns:a="http://schemas.openxmlformats.org/drawingml/2006/main">
+          <a:bodyPr/>
+          <a:p/>
+        </p:txBody>
       </p:sp>
       <p:sp>
         <p:nvSpPr>
@@ -3170,6 +3210,10 @@
             <a:prstDash val="solid"/>
           </a:ln>
         </p:spPr>
+        <p:txBody xmlns:a="http://schemas.openxmlformats.org/drawingml/2006/main">
+          <a:bodyPr/>
+          <a:p/>
+        </p:txBody>
       </p:sp>
       <p:sp>
         <p:nvSpPr>
@@ -3343,6 +3387,10 @@
             <a:prstDash val="solid"/>
           </a:ln>
         </p:spPr>
+        <p:txBody xmlns:a="http://schemas.openxmlformats.org/drawingml/2006/main">
+          <a:bodyPr/>
+          <a:p/>
+        </p:txBody>
       </p:sp>
       <p:sp>
         <p:nvSpPr>
@@ -3378,6 +3426,10 @@
             <a:prstDash val="solid"/>
           </a:ln>
         </p:spPr>
+        <p:txBody xmlns:a="http://schemas.openxmlformats.org/drawingml/2006/main">
+          <a:bodyPr/>
+          <a:p/>
+        </p:txBody>
       </p:sp>
       <p:sp>
         <p:nvSpPr>
@@ -3551,6 +3603,10 @@
             <a:prstDash val="solid"/>
           </a:ln>
         </p:spPr>
+        <p:txBody xmlns:a="http://schemas.openxmlformats.org/drawingml/2006/main">
+          <a:bodyPr/>
+          <a:p/>
+        </p:txBody>
       </p:sp>
       <p:sp>
         <p:nvSpPr>
@@ -3586,6 +3642,10 @@
             <a:prstDash val="solid"/>
           </a:ln>
         </p:spPr>
+        <p:txBody xmlns:a="http://schemas.openxmlformats.org/drawingml/2006/main">
+          <a:bodyPr/>
+          <a:p/>
+        </p:txBody>
       </p:sp>
       <p:sp>
         <p:nvSpPr>
@@ -3759,6 +3819,10 @@
             <a:prstDash val="solid"/>
           </a:ln>
         </p:spPr>
+        <p:txBody xmlns:a="http://schemas.openxmlformats.org/drawingml/2006/main">
+          <a:bodyPr/>
+          <a:p/>
+        </p:txBody>
       </p:sp>
       <p:sp>
         <p:nvSpPr>
@@ -4053,6 +4117,10 @@
             <a:prstDash val="solid"/>
           </a:ln>
         </p:spPr>
+        <p:txBody xmlns:a="http://schemas.openxmlformats.org/drawingml/2006/main">
+          <a:bodyPr/>
+          <a:p/>
+        </p:txBody>
       </p:sp>
       <p:sp>
         <p:nvSpPr>
@@ -4289,6 +4357,10 @@
             <a:prstDash val="solid"/>
           </a:ln>
         </p:spPr>
+        <p:txBody xmlns:a="http://schemas.openxmlformats.org/drawingml/2006/main">
+          <a:bodyPr/>
+          <a:p/>
+        </p:txBody>
       </p:sp>
       <p:sp>
         <p:nvSpPr>
@@ -4525,6 +4597,10 @@
             <a:prstDash val="solid"/>
           </a:ln>
         </p:spPr>
+        <p:txBody xmlns:a="http://schemas.openxmlformats.org/drawingml/2006/main">
+          <a:bodyPr/>
+          <a:p/>
+        </p:txBody>
       </p:sp>
       <p:sp>
         <p:nvSpPr>
@@ -4562,6 +4638,10 @@
             <a:prstDash val="solid"/>
           </a:ln>
         </p:spPr>
+        <p:txBody xmlns:a="http://schemas.openxmlformats.org/drawingml/2006/main">
+          <a:bodyPr/>
+          <a:p/>
+        </p:txBody>
       </p:sp>
       <p:sp>
         <p:nvSpPr>
@@ -4798,6 +4878,10 @@
             <a:prstDash val="solid"/>
           </a:ln>
         </p:spPr>
+        <p:txBody xmlns:a="http://schemas.openxmlformats.org/drawingml/2006/main">
+          <a:bodyPr/>
+          <a:p/>
+        </p:txBody>
       </p:sp>
       <p:sp>
         <p:nvSpPr>
@@ -4988,6 +5072,10 @@
             <a:prstDash val="solid"/>
           </a:ln>
         </p:spPr>
+        <p:txBody xmlns:a="http://schemas.openxmlformats.org/drawingml/2006/main">
+          <a:bodyPr/>
+          <a:p/>
+        </p:txBody>
       </p:sp>
       <p:sp>
         <p:nvSpPr>
@@ -5115,6 +5203,10 @@
             <a:prstDash val="solid"/>
           </a:ln>
         </p:spPr>
+        <p:txBody xmlns:a="http://schemas.openxmlformats.org/drawingml/2006/main">
+          <a:bodyPr/>
+          <a:p/>
+        </p:txBody>
       </p:sp>
       <p:sp>
         <p:nvSpPr>
@@ -5409,6 +5501,10 @@
             <a:prstDash val="solid"/>
           </a:ln>
         </p:spPr>
+        <p:txBody xmlns:a="http://schemas.openxmlformats.org/drawingml/2006/main">
+          <a:bodyPr/>
+          <a:p/>
+        </p:txBody>
       </p:sp>
       <p:sp>
         <p:nvSpPr>
@@ -5488,6 +5584,10 @@
             <a:prstDash val="solid"/>
           </a:ln>
         </p:spPr>
+        <p:txBody xmlns:a="http://schemas.openxmlformats.org/drawingml/2006/main">
+          <a:bodyPr/>
+          <a:p/>
+        </p:txBody>
       </p:sp>
       <p:sp>
         <p:nvSpPr>
@@ -5659,6 +5759,10 @@
             <a:prstDash val="solid"/>
           </a:ln>
         </p:spPr>
+        <p:txBody xmlns:a="http://schemas.openxmlformats.org/drawingml/2006/main">
+          <a:bodyPr/>
+          <a:p/>
+        </p:txBody>
       </p:sp>
       <p:sp>
         <p:nvSpPr>
@@ -5830,6 +5934,10 @@
             <a:prstDash val="solid"/>
           </a:ln>
         </p:spPr>
+        <p:txBody xmlns:a="http://schemas.openxmlformats.org/drawingml/2006/main">
+          <a:bodyPr/>
+          <a:p/>
+        </p:txBody>
       </p:sp>
       <p:sp>
         <p:nvSpPr>
@@ -6001,6 +6109,10 @@
             <a:prstDash val="solid"/>
           </a:ln>
         </p:spPr>
+        <p:txBody xmlns:a="http://schemas.openxmlformats.org/drawingml/2006/main">
+          <a:bodyPr/>
+          <a:p/>
+        </p:txBody>
       </p:sp>
       <p:sp>
         <p:nvSpPr>
@@ -6172,6 +6284,10 @@
             <a:prstDash val="solid"/>
           </a:ln>
         </p:spPr>
+        <p:txBody xmlns:a="http://schemas.openxmlformats.org/drawingml/2006/main">
+          <a:bodyPr/>
+          <a:p/>
+        </p:txBody>
       </p:sp>
       <p:sp>
         <p:nvSpPr>
@@ -6345,6 +6461,10 @@
             <a:prstDash val="solid"/>
           </a:ln>
         </p:spPr>
+        <p:txBody xmlns:a="http://schemas.openxmlformats.org/drawingml/2006/main">
+          <a:bodyPr/>
+          <a:p/>
+        </p:txBody>
       </p:sp>
       <p:sp>
         <p:nvSpPr>
@@ -6641,6 +6761,10 @@
             <a:prstDash val="solid"/>
           </a:ln>
         </p:spPr>
+        <p:txBody xmlns:a="http://schemas.openxmlformats.org/drawingml/2006/main">
+          <a:bodyPr/>
+          <a:p/>
+        </p:txBody>
       </p:sp>
       <p:sp>
         <p:nvSpPr>
@@ -6674,6 +6798,10 @@
             <a:prstDash val="solid"/>
           </a:ln>
         </p:spPr>
+        <p:txBody xmlns:a="http://schemas.openxmlformats.org/drawingml/2006/main">
+          <a:bodyPr/>
+          <a:p/>
+        </p:txBody>
       </p:sp>
       <p:sp>
         <p:nvSpPr>
@@ -6922,6 +7050,10 @@
             <a:prstDash val="solid"/>
           </a:ln>
         </p:spPr>
+        <p:txBody xmlns:a="http://schemas.openxmlformats.org/drawingml/2006/main">
+          <a:bodyPr/>
+          <a:p/>
+        </p:txBody>
       </p:sp>
       <p:sp>
         <p:nvSpPr>
@@ -7049,6 +7181,10 @@
             <a:prstDash val="solid"/>
           </a:ln>
         </p:spPr>
+        <p:txBody xmlns:a="http://schemas.openxmlformats.org/drawingml/2006/main">
+          <a:bodyPr/>
+          <a:p/>
+        </p:txBody>
       </p:sp>
       <p:sp>
         <p:nvSpPr>
@@ -7176,6 +7312,10 @@
             <a:prstDash val="solid"/>
           </a:ln>
         </p:spPr>
+        <p:txBody xmlns:a="http://schemas.openxmlformats.org/drawingml/2006/main">
+          <a:bodyPr/>
+          <a:p/>
+        </p:txBody>
       </p:sp>
       <p:sp>
         <p:nvSpPr>
@@ -7303,6 +7443,10 @@
             <a:prstDash val="solid"/>
           </a:ln>
         </p:spPr>
+        <p:txBody xmlns:a="http://schemas.openxmlformats.org/drawingml/2006/main">
+          <a:bodyPr/>
+          <a:p/>
+        </p:txBody>
       </p:sp>
       <p:sp>
         <p:nvSpPr>
@@ -7579,6 +7723,10 @@
             <a:prstDash val="solid"/>
           </a:ln>
         </p:spPr>
+        <p:txBody xmlns:a="http://schemas.openxmlformats.org/drawingml/2006/main">
+          <a:bodyPr/>
+          <a:p/>
+        </p:txBody>
       </p:sp>
       <p:sp>
         <p:nvSpPr>
@@ -7827,6 +7975,10 @@
             <a:prstDash val="solid"/>
           </a:ln>
         </p:spPr>
+        <p:txBody xmlns:a="http://schemas.openxmlformats.org/drawingml/2006/main">
+          <a:bodyPr/>
+          <a:p/>
+        </p:txBody>
       </p:sp>
       <p:sp>
         <p:nvSpPr>
@@ -7954,6 +8106,10 @@
             <a:prstDash val="solid"/>
           </a:ln>
         </p:spPr>
+        <p:txBody xmlns:a="http://schemas.openxmlformats.org/drawingml/2006/main">
+          <a:bodyPr/>
+          <a:p/>
+        </p:txBody>
       </p:sp>
       <p:sp>
         <p:nvSpPr>
@@ -8081,6 +8237,10 @@
             <a:prstDash val="solid"/>
           </a:ln>
         </p:spPr>
+        <p:txBody xmlns:a="http://schemas.openxmlformats.org/drawingml/2006/main">
+          <a:bodyPr/>
+          <a:p/>
+        </p:txBody>
       </p:sp>
       <p:sp>
         <p:nvSpPr>
@@ -8208,6 +8368,10 @@
             <a:prstDash val="dash"/>
           </a:ln>
         </p:spPr>
+        <p:txBody xmlns:a="http://schemas.openxmlformats.org/drawingml/2006/main">
+          <a:bodyPr/>
+          <a:p/>
+        </p:txBody>
       </p:sp>
       <p:sp>
         <p:nvSpPr>
@@ -8335,6 +8499,10 @@
             <a:prstDash val="solid"/>
           </a:ln>
         </p:spPr>
+        <p:txBody xmlns:a="http://schemas.openxmlformats.org/drawingml/2006/main">
+          <a:bodyPr/>
+          <a:p/>
+        </p:txBody>
       </p:sp>
       <p:sp>
         <p:nvSpPr>
@@ -8765,6 +8933,10 @@
             <a:prstDash val="solid"/>
           </a:ln>
         </p:spPr>
+        <p:txBody xmlns:a="http://schemas.openxmlformats.org/drawingml/2006/main">
+          <a:bodyPr/>
+          <a:p/>
+        </p:txBody>
       </p:sp>
       <p:sp>
         <p:nvSpPr>
@@ -8892,6 +9064,10 @@
             <a:prstDash val="solid"/>
           </a:ln>
         </p:spPr>
+        <p:txBody xmlns:a="http://schemas.openxmlformats.org/drawingml/2006/main">
+          <a:bodyPr/>
+          <a:p/>
+        </p:txBody>
       </p:sp>
       <p:sp>
         <p:nvSpPr>
@@ -8925,6 +9101,10 @@
             <a:prstDash val="solid"/>
           </a:ln>
         </p:spPr>
+        <p:txBody xmlns:a="http://schemas.openxmlformats.org/drawingml/2006/main">
+          <a:bodyPr/>
+          <a:p/>
+        </p:txBody>
       </p:sp>
       <p:sp>
         <p:nvSpPr>
@@ -9141,6 +9321,10 @@
             <a:prstDash val="solid"/>
           </a:ln>
         </p:spPr>
+        <p:txBody xmlns:a="http://schemas.openxmlformats.org/drawingml/2006/main">
+          <a:bodyPr/>
+          <a:p/>
+        </p:txBody>
       </p:sp>
       <p:sp>
         <p:nvSpPr>
@@ -9268,6 +9452,10 @@
             <a:prstDash val="solid"/>
           </a:ln>
         </p:spPr>
+        <p:txBody xmlns:a="http://schemas.openxmlformats.org/drawingml/2006/main">
+          <a:bodyPr/>
+          <a:p/>
+        </p:txBody>
       </p:sp>
       <p:sp>
         <p:nvSpPr>
@@ -9301,6 +9489,10 @@
             <a:prstDash val="solid"/>
           </a:ln>
         </p:spPr>
+        <p:txBody xmlns:a="http://schemas.openxmlformats.org/drawingml/2006/main">
+          <a:bodyPr/>
+          <a:p/>
+        </p:txBody>
       </p:sp>
       <p:sp>
         <p:nvSpPr>
@@ -9428,6 +9620,10 @@
             <a:prstDash val="solid"/>
           </a:ln>
         </p:spPr>
+        <p:txBody xmlns:a="http://schemas.openxmlformats.org/drawingml/2006/main">
+          <a:bodyPr/>
+          <a:p/>
+        </p:txBody>
       </p:sp>
       <p:sp>
         <p:nvSpPr>
@@ -9676,6 +9872,10 @@
             <a:prstDash val="solid"/>
           </a:ln>
         </p:spPr>
+        <p:txBody xmlns:a="http://schemas.openxmlformats.org/drawingml/2006/main">
+          <a:bodyPr/>
+          <a:p/>
+        </p:txBody>
       </p:sp>
       <p:sp>
         <p:nvSpPr>
@@ -9866,6 +10066,10 @@
             <a:prstDash val="solid"/>
           </a:ln>
         </p:spPr>
+        <p:txBody xmlns:a="http://schemas.openxmlformats.org/drawingml/2006/main">
+          <a:bodyPr/>
+          <a:p/>
+        </p:txBody>
       </p:sp>
       <p:sp>
         <p:nvSpPr>
@@ -10056,6 +10260,10 @@
             <a:prstDash val="solid"/>
           </a:ln>
         </p:spPr>
+        <p:txBody xmlns:a="http://schemas.openxmlformats.org/drawingml/2006/main">
+          <a:bodyPr/>
+          <a:p/>
+        </p:txBody>
       </p:sp>
       <p:sp>
         <p:nvSpPr>
@@ -10246,6 +10454,10 @@
             <a:prstDash val="solid"/>
           </a:ln>
         </p:spPr>
+        <p:txBody xmlns:a="http://schemas.openxmlformats.org/drawingml/2006/main">
+          <a:bodyPr/>
+          <a:p/>
+        </p:txBody>
       </p:sp>
       <p:sp>
         <p:nvSpPr>
@@ -10494,6 +10706,10 @@
             <a:prstDash val="solid"/>
           </a:ln>
         </p:spPr>
+        <p:txBody xmlns:a="http://schemas.openxmlformats.org/drawingml/2006/main">
+          <a:bodyPr/>
+          <a:p/>
+        </p:txBody>
       </p:sp>
       <p:sp>
         <p:nvSpPr>
@@ -10621,6 +10837,10 @@
             <a:prstDash val="solid"/>
           </a:ln>
         </p:spPr>
+        <p:txBody xmlns:a="http://schemas.openxmlformats.org/drawingml/2006/main">
+          <a:bodyPr/>
+          <a:p/>
+        </p:txBody>
       </p:sp>
       <p:sp>
         <p:nvSpPr>
@@ -10748,6 +10968,10 @@
             <a:prstDash val="solid"/>
           </a:ln>
         </p:spPr>
+        <p:txBody xmlns:a="http://schemas.openxmlformats.org/drawingml/2006/main">
+          <a:bodyPr/>
+          <a:p/>
+        </p:txBody>
       </p:sp>
       <p:sp>
         <p:nvSpPr>
@@ -10875,6 +11099,10 @@
             <a:prstDash val="solid"/>
           </a:ln>
         </p:spPr>
+        <p:txBody xmlns:a="http://schemas.openxmlformats.org/drawingml/2006/main">
+          <a:bodyPr/>
+          <a:p/>
+        </p:txBody>
       </p:sp>
       <p:sp>
         <p:nvSpPr>

</xml_diff>

<commit_message>
docs: reconciliation semantics and the 61-test baseline
</commit_message>
<xml_diff>
--- a/docs/Razorpay_Buildathon_Action_Firewall_Deck.pptx
+++ b/docs/Razorpay_Buildathon_Action_Firewall_Deck.pptx
@@ -2573,7 +2573,7 @@
                 <a:ea typeface="Courier New"/>
                 <a:cs typeface="Courier New"/>
               </a:rPr>
-              <a:t>Razorpay MCP-compatible actuator  ·  deterministic policy  ·  54 tests  ·  offline demo</a:t>
+              <a:t>Razorpay MCP-compatible actuator  ·  deterministic policy  ·  61 tests  ·  offline demo</a:t>
             </a:r>
             <a:endParaRPr sz="1050"/>
           </a:p>
@@ -2918,7 +2918,7 @@
                 <a:ea typeface="Courier New"/>
                 <a:cs typeface="Courier New"/>
               </a:rPr>
-              <a:t>pytest -q → 54 passed   ·   npm audit → 0   ·   offline rehearsal → passed</a:t>
+              <a:t>pytest -q → 61 passed   ·   npm audit → 0   ·   offline rehearsal → passed</a:t>
             </a:r>
             <a:endParaRPr sz="1050"/>
           </a:p>

</xml_diff>

<commit_message>
docs: publish final Action Firewall evidence
</commit_message>
<xml_diff>
--- a/docs/Razorpay_Buildathon_Action_Firewall_Deck.pptx
+++ b/docs/Razorpay_Buildathon_Action_Firewall_Deck.pptx
@@ -3470,7 +3470,7 @@
               </a:defRPr>
             </a:pPr>
             <a:r>
-              <a:t>Razorpay MCP-compatible actuator · deterministic policy · 102 tests · offline demo</a:t>
+              <a:t>Razorpay MCP-compatible actuator · deterministic policy · 142 tests · offline demo</a:t>
             </a:r>
           </a:p>
         </p:txBody>
@@ -3711,7 +3711,7 @@
               </a:defRPr>
             </a:pPr>
             <a:r>
-              <a:t>• 102 passing backend tests covering pure spend policy, envelope drafts, concurrency, and reconciliation</a:t>
+              <a:t>• 142 passing backend tests covering pure spend policy, envelope drafts, concurrency, and reconciliation</a:t>
             </a:r>
             <a:br/>
             <a:r>
@@ -3798,7 +3798,7 @@
               </a:defRPr>
             </a:pPr>
             <a:r>
-              <a:t>pytest → 102 passed · 650 eval cases · npm audit → 0 · offline rehearsals → passed</a:t>
+              <a:t>pytest → 142 passed · 650 eval cases · npm audit → 0 · offline rehearsals → passed</a:t>
             </a:r>
           </a:p>
         </p:txBody>
@@ -6981,7 +6981,7 @@
               </a:defRPr>
             </a:pPr>
             <a:r>
-              <a:t>102</a:t>
+              <a:t>142</a:t>
             </a:r>
           </a:p>
           <a:p>

</xml_diff>

<commit_message>
docs: sync test counts across docs, demo script, and pitch decks to 146
</commit_message>
<xml_diff>
--- a/docs/Razorpay_Buildathon_Action_Firewall_Deck.pptx
+++ b/docs/Razorpay_Buildathon_Action_Firewall_Deck.pptx
@@ -3470,7 +3470,7 @@
               </a:defRPr>
             </a:pPr>
             <a:r>
-              <a:t>Razorpay MCP-compatible actuator · deterministic policy · 142 tests · offline demo</a:t>
+              <a:t>Razorpay MCP-compatible actuator · deterministic policy · 102 tests · offline demo</a:t>
             </a:r>
           </a:p>
         </p:txBody>
@@ -3711,7 +3711,7 @@
               </a:defRPr>
             </a:pPr>
             <a:r>
-              <a:t>• 142 passing backend tests covering pure spend policy, envelope drafts, concurrency, and reconciliation</a:t>
+              <a:t>• 146 passing backend tests covering pure spend policy, envelope drafts, concurrency, and reconciliation</a:t>
             </a:r>
             <a:br/>
             <a:r>
@@ -3798,7 +3798,7 @@
               </a:defRPr>
             </a:pPr>
             <a:r>
-              <a:t>pytest → 142 passed · 650 eval cases · npm audit → 0 · offline rehearsals → passed</a:t>
+              <a:t>pytest → 146 passed · 650 eval cases · npm audit → 0 · offline rehearsals → passed</a:t>
             </a:r>
           </a:p>
         </p:txBody>
@@ -6981,7 +6981,7 @@
               </a:defRPr>
             </a:pPr>
             <a:r>
-              <a:t>142</a:t>
+              <a:t>146</a:t>
             </a:r>
           </a:p>
           <a:p>

</xml_diff>

<commit_message>
docs: align test count to 147 across all decks, demo scripts, and readme
</commit_message>
<xml_diff>
--- a/docs/Razorpay_Buildathon_Action_Firewall_Deck.pptx
+++ b/docs/Razorpay_Buildathon_Action_Firewall_Deck.pptx
@@ -3470,7 +3470,7 @@
               </a:defRPr>
             </a:pPr>
             <a:r>
-              <a:t>Razorpay MCP-compatible actuator · deterministic policy · 102 tests · offline demo</a:t>
+              <a:t>Razorpay MCP-compatible actuator · deterministic policy · 147 tests · offline demo</a:t>
             </a:r>
           </a:p>
         </p:txBody>
@@ -3711,7 +3711,7 @@
               </a:defRPr>
             </a:pPr>
             <a:r>
-              <a:t>• 146 passing backend tests covering pure spend policy, envelope drafts, concurrency, and reconciliation</a:t>
+              <a:t>• 147 passing backend tests covering pure spend policy, envelope drafts, voice boundaries, concurrency, and reconciliation</a:t>
             </a:r>
             <a:br/>
             <a:r>
@@ -3798,7 +3798,7 @@
               </a:defRPr>
             </a:pPr>
             <a:r>
-              <a:t>pytest → 146 passed · 650 eval cases · npm audit → 0 · offline rehearsals → passed</a:t>
+              <a:t>pytest → 147 passed · 650 eval cases · npm audit → 0 · offline rehearsals → passed</a:t>
             </a:r>
           </a:p>
         </p:txBody>
@@ -6981,7 +6981,7 @@
               </a:defRPr>
             </a:pPr>
             <a:r>
-              <a:t>146</a:t>
+              <a:t>147</a:t>
             </a:r>
           </a:p>
           <a:p>
@@ -6999,7 +6999,7 @@
             <a:br/>
             <a:br/>
             <a:r>
-              <a:t>Exact suite: policy limits, envelopes, receipts, HTTP contracts, and concurrency.</a:t>
+              <a:t>Exact suite: policy limits, envelopes, receipts, voice boundaries, HTTP contracts, and concurrency.</a:t>
             </a:r>
           </a:p>
         </p:txBody>

</xml_diff>